<commit_message>
I forgot stupid tiny edits!!!
</commit_message>
<xml_diff>
--- a/Slides/Ch3.1-Roscoe26.pptx
+++ b/Slides/Ch3.1-Roscoe26.pptx
@@ -26698,13 +26698,13 @@
               </a:spcBef>
             </a:pPr>
             <a:r>
-              <a:rPr lang="en-US" dirty="0">
+              <a:rPr lang="en-US">
                 <a:latin typeface="Times New Roman"/>
                 <a:ea typeface="Times New Roman"/>
                 <a:cs typeface="Times New Roman"/>
                 <a:sym typeface="Times New Roman"/>
               </a:rPr>
-              <a:t>Chapter 3.1</a:t>
+              <a:t>Chapter 3.1-3.3</a:t>
             </a:r>
             <a:endParaRPr dirty="0"/>
           </a:p>

</xml_diff>